<commit_message>
updates in the report
</commit_message>
<xml_diff>
--- a/slides/White Blue Modern Minimalist Project Presentation.pptx
+++ b/slides/White Blue Modern Minimalist Project Presentation.pptx
@@ -1,52 +1,52 @@
 
 <file path=ppt/presentation.xml><?xml version="1.0" encoding="utf-8"?>
-<p:presentation xmlns:a="http://schemas.openxmlformats.org/drawingml/2006/main" xmlns:r="http://schemas.openxmlformats.org/officeDocument/2006/relationships" xmlns:p="http://schemas.openxmlformats.org/presentationml/2006/main" saveSubsetFonts="1" embedTrueTypeFonts="true">
+<p:presentation xmlns:a="http://schemas.openxmlformats.org/drawingml/2006/main" xmlns:r="http://schemas.openxmlformats.org/officeDocument/2006/relationships" xmlns:p="http://schemas.openxmlformats.org/presentationml/2006/main" embedTrueTypeFonts="1" saveSubsetFonts="1">
   <p:sldMasterIdLst>
     <p:sldMasterId id="2147483648" r:id="rId1"/>
   </p:sldMasterIdLst>
   <p:sldIdLst>
-    <p:sldId id="256" r:id="rId6"/>
-    <p:sldId id="257" r:id="rId7"/>
-    <p:sldId id="258" r:id="rId8"/>
-    <p:sldId id="259" r:id="rId9"/>
-    <p:sldId id="260" r:id="rId10"/>
-    <p:sldId id="261" r:id="rId11"/>
-    <p:sldId id="262" r:id="rId12"/>
+    <p:sldId id="256" r:id="rId2"/>
+    <p:sldId id="257" r:id="rId3"/>
+    <p:sldId id="258" r:id="rId4"/>
+    <p:sldId id="259" r:id="rId5"/>
+    <p:sldId id="260" r:id="rId6"/>
+    <p:sldId id="261" r:id="rId7"/>
+    <p:sldId id="262" r:id="rId8"/>
   </p:sldIdLst>
   <p:sldSz cx="18288000" cy="10287000"/>
   <p:notesSz cx="6858000" cy="9144000"/>
   <p:embeddedFontLst>
     <p:embeddedFont>
-      <p:font typeface="Fredoka" charset="1" panose="02000000000000000000"/>
+      <p:font typeface="Beautifully Delicious Script Bold" panose="020B0604020202020204" charset="0"/>
+      <p:regular r:id="rId9"/>
+    </p:embeddedFont>
+    <p:embeddedFont>
+      <p:font typeface="Fredoka" panose="020B0604020202020204" charset="0"/>
+      <p:regular r:id="rId10"/>
+    </p:embeddedFont>
+    <p:embeddedFont>
+      <p:font typeface="Poppins" panose="020B0502040204020203" pitchFamily="2" charset="0"/>
+      <p:regular r:id="rId11"/>
+    </p:embeddedFont>
+    <p:embeddedFont>
+      <p:font typeface="Poppins Bold" panose="020B0604020202020204" charset="0"/>
+      <p:regular r:id="rId12"/>
+    </p:embeddedFont>
+    <p:embeddedFont>
+      <p:font typeface="Poppins Bold Italics" panose="020B0604020202020204" charset="0"/>
       <p:regular r:id="rId13"/>
     </p:embeddedFont>
     <p:embeddedFont>
-      <p:font typeface="Roca Two" charset="1" panose="00000500000000000000"/>
+      <p:font typeface="Roca Two" panose="020B0604020202020204" charset="0"/>
       <p:regular r:id="rId14"/>
     </p:embeddedFont>
     <p:embeddedFont>
-      <p:font typeface="Poppins Bold" charset="1" panose="00000800000000000000"/>
+      <p:font typeface="Roca Two Bold" panose="020B0604020202020204" charset="0"/>
       <p:regular r:id="rId15"/>
     </p:embeddedFont>
     <p:embeddedFont>
-      <p:font typeface="Poppins Bold Italics" charset="1" panose="00000800000000000000"/>
+      <p:font typeface="Times New Roman MT Bold" panose="020B0604020202020204" charset="0"/>
       <p:regular r:id="rId16"/>
-    </p:embeddedFont>
-    <p:embeddedFont>
-      <p:font typeface="Poppins" charset="1" panose="00000500000000000000"/>
-      <p:regular r:id="rId17"/>
-    </p:embeddedFont>
-    <p:embeddedFont>
-      <p:font typeface="Times New Roman MT Bold" charset="1" panose="02030802070405020303"/>
-      <p:regular r:id="rId18"/>
-    </p:embeddedFont>
-    <p:embeddedFont>
-      <p:font typeface="Roca Two Bold" charset="1" panose="00000800000000000000"/>
-      <p:regular r:id="rId19"/>
-    </p:embeddedFont>
-    <p:embeddedFont>
-      <p:font typeface="Beautifully Delicious Script Bold" charset="1" panose="00000800000000000000"/>
-      <p:regular r:id="rId20"/>
     </p:embeddedFont>
   </p:embeddedFontLst>
   <p:defaultTextStyle>
@@ -144,6 +144,22 @@
       </a:defRPr>
     </a:lvl9pPr>
   </p:defaultTextStyle>
+  <p:extLst>
+    <p:ext uri="{EFAFB233-063F-42B5-8137-9DF3F51BA10A}">
+      <p15:sldGuideLst xmlns:p15="http://schemas.microsoft.com/office/powerpoint/2012/main">
+        <p15:guide id="1" orient="horz" pos="2160">
+          <p15:clr>
+            <a:srgbClr val="A4A3A4"/>
+          </p15:clr>
+        </p15:guide>
+        <p15:guide id="2" pos="2880">
+          <p15:clr>
+            <a:srgbClr val="A4A3A4"/>
+          </p15:clr>
+        </p15:guide>
+      </p15:sldGuideLst>
+    </p:ext>
+  </p:extLst>
 </p:presentation>
 </file>
 
@@ -185,10 +201,9 @@
           <a:lstStyle/>
           <a:p>
             <a:r>
-              <a:rPr lang="en-US" smtClean="0"/>
+              <a:rPr lang="en-US"/>
               <a:t>Click to edit Master title style</a:t>
             </a:r>
-            <a:endParaRPr lang="en-US"/>
           </a:p>
         </p:txBody>
       </p:sp>
@@ -304,10 +319,9 @@
           </a:lstStyle>
           <a:p>
             <a:r>
-              <a:rPr lang="en-US" smtClean="0"/>
+              <a:rPr lang="en-US"/>
               <a:t>Click to edit Master subtitle style</a:t>
             </a:r>
-            <a:endParaRPr lang="en-US"/>
           </a:p>
         </p:txBody>
       </p:sp>
@@ -329,7 +343,7 @@
             <a:fld id="{1D8BD707-D9CF-40AE-B4C6-C98DA3205C09}" type="datetimeFigureOut">
               <a:rPr lang="en-US" smtClean="0"/>
               <a:pPr/>
-              <a:t>8/1/2011</a:t>
+              <a:t>3/29/2026</a:t>
             </a:fld>
             <a:endParaRPr lang="en-US"/>
           </a:p>
@@ -419,10 +433,9 @@
           <a:lstStyle/>
           <a:p>
             <a:r>
-              <a:rPr lang="en-US" smtClean="0"/>
+              <a:rPr lang="en-US"/>
               <a:t>Click to edit Master title style</a:t>
             </a:r>
-            <a:endParaRPr lang="en-US"/>
           </a:p>
         </p:txBody>
       </p:sp>
@@ -443,38 +456,37 @@
           <a:p>
             <a:pPr lvl="0"/>
             <a:r>
-              <a:rPr lang="en-US" smtClean="0"/>
+              <a:rPr lang="en-US"/>
               <a:t>Click to edit Master text styles</a:t>
             </a:r>
           </a:p>
           <a:p>
             <a:pPr lvl="1"/>
             <a:r>
-              <a:rPr lang="en-US" smtClean="0"/>
+              <a:rPr lang="en-US"/>
               <a:t>Second level</a:t>
             </a:r>
           </a:p>
           <a:p>
             <a:pPr lvl="2"/>
             <a:r>
-              <a:rPr lang="en-US" smtClean="0"/>
+              <a:rPr lang="en-US"/>
               <a:t>Third level</a:t>
             </a:r>
           </a:p>
           <a:p>
             <a:pPr lvl="3"/>
             <a:r>
-              <a:rPr lang="en-US" smtClean="0"/>
+              <a:rPr lang="en-US"/>
               <a:t>Fourth level</a:t>
             </a:r>
           </a:p>
           <a:p>
             <a:pPr lvl="4"/>
             <a:r>
-              <a:rPr lang="en-US" smtClean="0"/>
+              <a:rPr lang="en-US"/>
               <a:t>Fifth level</a:t>
             </a:r>
-            <a:endParaRPr lang="en-US"/>
           </a:p>
         </p:txBody>
       </p:sp>
@@ -496,7 +508,7 @@
             <a:fld id="{1D8BD707-D9CF-40AE-B4C6-C98DA3205C09}" type="datetimeFigureOut">
               <a:rPr lang="en-US" smtClean="0"/>
               <a:pPr/>
-              <a:t>8/1/2011</a:t>
+              <a:t>3/29/2026</a:t>
             </a:fld>
             <a:endParaRPr lang="en-US"/>
           </a:p>
@@ -591,10 +603,9 @@
           <a:lstStyle/>
           <a:p>
             <a:r>
-              <a:rPr lang="en-US" smtClean="0"/>
+              <a:rPr lang="en-US"/>
               <a:t>Click to edit Master title style</a:t>
             </a:r>
-            <a:endParaRPr lang="en-US"/>
           </a:p>
         </p:txBody>
       </p:sp>
@@ -620,38 +631,37 @@
           <a:p>
             <a:pPr lvl="0"/>
             <a:r>
-              <a:rPr lang="en-US" smtClean="0"/>
+              <a:rPr lang="en-US"/>
               <a:t>Click to edit Master text styles</a:t>
             </a:r>
           </a:p>
           <a:p>
             <a:pPr lvl="1"/>
             <a:r>
-              <a:rPr lang="en-US" smtClean="0"/>
+              <a:rPr lang="en-US"/>
               <a:t>Second level</a:t>
             </a:r>
           </a:p>
           <a:p>
             <a:pPr lvl="2"/>
             <a:r>
-              <a:rPr lang="en-US" smtClean="0"/>
+              <a:rPr lang="en-US"/>
               <a:t>Third level</a:t>
             </a:r>
           </a:p>
           <a:p>
             <a:pPr lvl="3"/>
             <a:r>
-              <a:rPr lang="en-US" smtClean="0"/>
+              <a:rPr lang="en-US"/>
               <a:t>Fourth level</a:t>
             </a:r>
           </a:p>
           <a:p>
             <a:pPr lvl="4"/>
             <a:r>
-              <a:rPr lang="en-US" smtClean="0"/>
+              <a:rPr lang="en-US"/>
               <a:t>Fifth level</a:t>
             </a:r>
-            <a:endParaRPr lang="en-US"/>
           </a:p>
         </p:txBody>
       </p:sp>
@@ -673,7 +683,7 @@
             <a:fld id="{1D8BD707-D9CF-40AE-B4C6-C98DA3205C09}" type="datetimeFigureOut">
               <a:rPr lang="en-US" smtClean="0"/>
               <a:pPr/>
-              <a:t>8/1/2011</a:t>
+              <a:t>3/29/2026</a:t>
             </a:fld>
             <a:endParaRPr lang="en-US"/>
           </a:p>
@@ -763,10 +773,9 @@
           <a:lstStyle/>
           <a:p>
             <a:r>
-              <a:rPr lang="en-US" smtClean="0"/>
+              <a:rPr lang="en-US"/>
               <a:t>Click to edit Master title style</a:t>
             </a:r>
-            <a:endParaRPr lang="en-US"/>
           </a:p>
         </p:txBody>
       </p:sp>
@@ -787,38 +796,37 @@
           <a:p>
             <a:pPr lvl="0"/>
             <a:r>
-              <a:rPr lang="en-US" smtClean="0"/>
+              <a:rPr lang="en-US"/>
               <a:t>Click to edit Master text styles</a:t>
             </a:r>
           </a:p>
           <a:p>
             <a:pPr lvl="1"/>
             <a:r>
-              <a:rPr lang="en-US" smtClean="0"/>
+              <a:rPr lang="en-US"/>
               <a:t>Second level</a:t>
             </a:r>
           </a:p>
           <a:p>
             <a:pPr lvl="2"/>
             <a:r>
-              <a:rPr lang="en-US" smtClean="0"/>
+              <a:rPr lang="en-US"/>
               <a:t>Third level</a:t>
             </a:r>
           </a:p>
           <a:p>
             <a:pPr lvl="3"/>
             <a:r>
-              <a:rPr lang="en-US" smtClean="0"/>
+              <a:rPr lang="en-US"/>
               <a:t>Fourth level</a:t>
             </a:r>
           </a:p>
           <a:p>
             <a:pPr lvl="4"/>
             <a:r>
-              <a:rPr lang="en-US" smtClean="0"/>
+              <a:rPr lang="en-US"/>
               <a:t>Fifth level</a:t>
             </a:r>
-            <a:endParaRPr lang="en-US"/>
           </a:p>
         </p:txBody>
       </p:sp>
@@ -840,7 +848,7 @@
             <a:fld id="{1D8BD707-D9CF-40AE-B4C6-C98DA3205C09}" type="datetimeFigureOut">
               <a:rPr lang="en-US" smtClean="0"/>
               <a:pPr/>
-              <a:t>8/1/2011</a:t>
+              <a:t>3/29/2026</a:t>
             </a:fld>
             <a:endParaRPr lang="en-US"/>
           </a:p>
@@ -939,10 +947,9 @@
           </a:lstStyle>
           <a:p>
             <a:r>
-              <a:rPr lang="en-US" smtClean="0"/>
+              <a:rPr lang="en-US"/>
               <a:t>Click to edit Master title style</a:t>
             </a:r>
-            <a:endParaRPr lang="en-US"/>
           </a:p>
         </p:txBody>
       </p:sp>
@@ -1059,7 +1066,7 @@
           <a:p>
             <a:pPr lvl="0"/>
             <a:r>
-              <a:rPr lang="en-US" smtClean="0"/>
+              <a:rPr lang="en-US"/>
               <a:t>Click to edit Master text styles</a:t>
             </a:r>
           </a:p>
@@ -1083,7 +1090,7 @@
             <a:fld id="{1D8BD707-D9CF-40AE-B4C6-C98DA3205C09}" type="datetimeFigureOut">
               <a:rPr lang="en-US" smtClean="0"/>
               <a:pPr/>
-              <a:t>8/1/2011</a:t>
+              <a:t>3/29/2026</a:t>
             </a:fld>
             <a:endParaRPr lang="en-US"/>
           </a:p>
@@ -1173,10 +1180,9 @@
           <a:lstStyle/>
           <a:p>
             <a:r>
-              <a:rPr lang="en-US" smtClean="0"/>
+              <a:rPr lang="en-US"/>
               <a:t>Click to edit Master title style</a:t>
             </a:r>
-            <a:endParaRPr lang="en-US"/>
           </a:p>
         </p:txBody>
       </p:sp>
@@ -1230,38 +1236,37 @@
           <a:p>
             <a:pPr lvl="0"/>
             <a:r>
-              <a:rPr lang="en-US" smtClean="0"/>
+              <a:rPr lang="en-US"/>
               <a:t>Click to edit Master text styles</a:t>
             </a:r>
           </a:p>
           <a:p>
             <a:pPr lvl="1"/>
             <a:r>
-              <a:rPr lang="en-US" smtClean="0"/>
+              <a:rPr lang="en-US"/>
               <a:t>Second level</a:t>
             </a:r>
           </a:p>
           <a:p>
             <a:pPr lvl="2"/>
             <a:r>
-              <a:rPr lang="en-US" smtClean="0"/>
+              <a:rPr lang="en-US"/>
               <a:t>Third level</a:t>
             </a:r>
           </a:p>
           <a:p>
             <a:pPr lvl="3"/>
             <a:r>
-              <a:rPr lang="en-US" smtClean="0"/>
+              <a:rPr lang="en-US"/>
               <a:t>Fourth level</a:t>
             </a:r>
           </a:p>
           <a:p>
             <a:pPr lvl="4"/>
             <a:r>
-              <a:rPr lang="en-US" smtClean="0"/>
+              <a:rPr lang="en-US"/>
               <a:t>Fifth level</a:t>
             </a:r>
-            <a:endParaRPr lang="en-US"/>
           </a:p>
         </p:txBody>
       </p:sp>
@@ -1315,38 +1320,37 @@
           <a:p>
             <a:pPr lvl="0"/>
             <a:r>
-              <a:rPr lang="en-US" smtClean="0"/>
+              <a:rPr lang="en-US"/>
               <a:t>Click to edit Master text styles</a:t>
             </a:r>
           </a:p>
           <a:p>
             <a:pPr lvl="1"/>
             <a:r>
-              <a:rPr lang="en-US" smtClean="0"/>
+              <a:rPr lang="en-US"/>
               <a:t>Second level</a:t>
             </a:r>
           </a:p>
           <a:p>
             <a:pPr lvl="2"/>
             <a:r>
-              <a:rPr lang="en-US" smtClean="0"/>
+              <a:rPr lang="en-US"/>
               <a:t>Third level</a:t>
             </a:r>
           </a:p>
           <a:p>
             <a:pPr lvl="3"/>
             <a:r>
-              <a:rPr lang="en-US" smtClean="0"/>
+              <a:rPr lang="en-US"/>
               <a:t>Fourth level</a:t>
             </a:r>
           </a:p>
           <a:p>
             <a:pPr lvl="4"/>
             <a:r>
-              <a:rPr lang="en-US" smtClean="0"/>
+              <a:rPr lang="en-US"/>
               <a:t>Fifth level</a:t>
             </a:r>
-            <a:endParaRPr lang="en-US"/>
           </a:p>
         </p:txBody>
       </p:sp>
@@ -1368,7 +1372,7 @@
             <a:fld id="{1D8BD707-D9CF-40AE-B4C6-C98DA3205C09}" type="datetimeFigureOut">
               <a:rPr lang="en-US" smtClean="0"/>
               <a:pPr/>
-              <a:t>8/1/2011</a:t>
+              <a:t>3/29/2026</a:t>
             </a:fld>
             <a:endParaRPr lang="en-US"/>
           </a:p>
@@ -1462,10 +1466,9 @@
           </a:lstStyle>
           <a:p>
             <a:r>
-              <a:rPr lang="en-US" smtClean="0"/>
+              <a:rPr lang="en-US"/>
               <a:t>Click to edit Master title style</a:t>
             </a:r>
-            <a:endParaRPr lang="en-US"/>
           </a:p>
         </p:txBody>
       </p:sp>
@@ -1528,7 +1531,7 @@
           <a:p>
             <a:pPr lvl="0"/>
             <a:r>
-              <a:rPr lang="en-US" smtClean="0"/>
+              <a:rPr lang="en-US"/>
               <a:t>Click to edit Master text styles</a:t>
             </a:r>
           </a:p>
@@ -1584,38 +1587,37 @@
           <a:p>
             <a:pPr lvl="0"/>
             <a:r>
-              <a:rPr lang="en-US" smtClean="0"/>
+              <a:rPr lang="en-US"/>
               <a:t>Click to edit Master text styles</a:t>
             </a:r>
           </a:p>
           <a:p>
             <a:pPr lvl="1"/>
             <a:r>
-              <a:rPr lang="en-US" smtClean="0"/>
+              <a:rPr lang="en-US"/>
               <a:t>Second level</a:t>
             </a:r>
           </a:p>
           <a:p>
             <a:pPr lvl="2"/>
             <a:r>
-              <a:rPr lang="en-US" smtClean="0"/>
+              <a:rPr lang="en-US"/>
               <a:t>Third level</a:t>
             </a:r>
           </a:p>
           <a:p>
             <a:pPr lvl="3"/>
             <a:r>
-              <a:rPr lang="en-US" smtClean="0"/>
+              <a:rPr lang="en-US"/>
               <a:t>Fourth level</a:t>
             </a:r>
           </a:p>
           <a:p>
             <a:pPr lvl="4"/>
             <a:r>
-              <a:rPr lang="en-US" smtClean="0"/>
+              <a:rPr lang="en-US"/>
               <a:t>Fifth level</a:t>
             </a:r>
-            <a:endParaRPr lang="en-US"/>
           </a:p>
         </p:txBody>
       </p:sp>
@@ -1678,7 +1680,7 @@
           <a:p>
             <a:pPr lvl="0"/>
             <a:r>
-              <a:rPr lang="en-US" smtClean="0"/>
+              <a:rPr lang="en-US"/>
               <a:t>Click to edit Master text styles</a:t>
             </a:r>
           </a:p>
@@ -1734,38 +1736,37 @@
           <a:p>
             <a:pPr lvl="0"/>
             <a:r>
-              <a:rPr lang="en-US" smtClean="0"/>
+              <a:rPr lang="en-US"/>
               <a:t>Click to edit Master text styles</a:t>
             </a:r>
           </a:p>
           <a:p>
             <a:pPr lvl="1"/>
             <a:r>
-              <a:rPr lang="en-US" smtClean="0"/>
+              <a:rPr lang="en-US"/>
               <a:t>Second level</a:t>
             </a:r>
           </a:p>
           <a:p>
             <a:pPr lvl="2"/>
             <a:r>
-              <a:rPr lang="en-US" smtClean="0"/>
+              <a:rPr lang="en-US"/>
               <a:t>Third level</a:t>
             </a:r>
           </a:p>
           <a:p>
             <a:pPr lvl="3"/>
             <a:r>
-              <a:rPr lang="en-US" smtClean="0"/>
+              <a:rPr lang="en-US"/>
               <a:t>Fourth level</a:t>
             </a:r>
           </a:p>
           <a:p>
             <a:pPr lvl="4"/>
             <a:r>
-              <a:rPr lang="en-US" smtClean="0"/>
+              <a:rPr lang="en-US"/>
               <a:t>Fifth level</a:t>
             </a:r>
-            <a:endParaRPr lang="en-US"/>
           </a:p>
         </p:txBody>
       </p:sp>
@@ -1787,7 +1788,7 @@
             <a:fld id="{1D8BD707-D9CF-40AE-B4C6-C98DA3205C09}" type="datetimeFigureOut">
               <a:rPr lang="en-US" smtClean="0"/>
               <a:pPr/>
-              <a:t>8/1/2011</a:t>
+              <a:t>3/29/2026</a:t>
             </a:fld>
             <a:endParaRPr lang="en-US"/>
           </a:p>
@@ -1877,10 +1878,9 @@
           <a:lstStyle/>
           <a:p>
             <a:r>
-              <a:rPr lang="en-US" smtClean="0"/>
+              <a:rPr lang="en-US"/>
               <a:t>Click to edit Master title style</a:t>
             </a:r>
-            <a:endParaRPr lang="en-US"/>
           </a:p>
         </p:txBody>
       </p:sp>
@@ -1902,7 +1902,7 @@
             <a:fld id="{1D8BD707-D9CF-40AE-B4C6-C98DA3205C09}" type="datetimeFigureOut">
               <a:rPr lang="en-US" smtClean="0"/>
               <a:pPr/>
-              <a:t>8/1/2011</a:t>
+              <a:t>3/29/2026</a:t>
             </a:fld>
             <a:endParaRPr lang="en-US"/>
           </a:p>
@@ -1994,7 +1994,7 @@
             <a:fld id="{1D8BD707-D9CF-40AE-B4C6-C98DA3205C09}" type="datetimeFigureOut">
               <a:rPr lang="en-US" smtClean="0"/>
               <a:pPr/>
-              <a:t>8/1/2011</a:t>
+              <a:t>3/29/2026</a:t>
             </a:fld>
             <a:endParaRPr lang="en-US"/>
           </a:p>
@@ -2093,10 +2093,9 @@
           </a:lstStyle>
           <a:p>
             <a:r>
-              <a:rPr lang="en-US" smtClean="0"/>
+              <a:rPr lang="en-US"/>
               <a:t>Click to edit Master title style</a:t>
             </a:r>
-            <a:endParaRPr lang="en-US"/>
           </a:p>
         </p:txBody>
       </p:sp>
@@ -2150,38 +2149,37 @@
           <a:p>
             <a:pPr lvl="0"/>
             <a:r>
-              <a:rPr lang="en-US" smtClean="0"/>
+              <a:rPr lang="en-US"/>
               <a:t>Click to edit Master text styles</a:t>
             </a:r>
           </a:p>
           <a:p>
             <a:pPr lvl="1"/>
             <a:r>
-              <a:rPr lang="en-US" smtClean="0"/>
+              <a:rPr lang="en-US"/>
               <a:t>Second level</a:t>
             </a:r>
           </a:p>
           <a:p>
             <a:pPr lvl="2"/>
             <a:r>
-              <a:rPr lang="en-US" smtClean="0"/>
+              <a:rPr lang="en-US"/>
               <a:t>Third level</a:t>
             </a:r>
           </a:p>
           <a:p>
             <a:pPr lvl="3"/>
             <a:r>
-              <a:rPr lang="en-US" smtClean="0"/>
+              <a:rPr lang="en-US"/>
               <a:t>Fourth level</a:t>
             </a:r>
           </a:p>
           <a:p>
             <a:pPr lvl="4"/>
             <a:r>
-              <a:rPr lang="en-US" smtClean="0"/>
+              <a:rPr lang="en-US"/>
               <a:t>Fifth level</a:t>
             </a:r>
-            <a:endParaRPr lang="en-US"/>
           </a:p>
         </p:txBody>
       </p:sp>
@@ -2244,7 +2242,7 @@
           <a:p>
             <a:pPr lvl="0"/>
             <a:r>
-              <a:rPr lang="en-US" smtClean="0"/>
+              <a:rPr lang="en-US"/>
               <a:t>Click to edit Master text styles</a:t>
             </a:r>
           </a:p>
@@ -2268,7 +2266,7 @@
             <a:fld id="{1D8BD707-D9CF-40AE-B4C6-C98DA3205C09}" type="datetimeFigureOut">
               <a:rPr lang="en-US" smtClean="0"/>
               <a:pPr/>
-              <a:t>8/1/2011</a:t>
+              <a:t>3/29/2026</a:t>
             </a:fld>
             <a:endParaRPr lang="en-US"/>
           </a:p>
@@ -2367,10 +2365,9 @@
           </a:lstStyle>
           <a:p>
             <a:r>
-              <a:rPr lang="en-US" smtClean="0"/>
+              <a:rPr lang="en-US"/>
               <a:t>Click to edit Master title style</a:t>
             </a:r>
-            <a:endParaRPr lang="en-US"/>
           </a:p>
         </p:txBody>
       </p:sp>
@@ -2494,7 +2491,7 @@
           <a:p>
             <a:pPr lvl="0"/>
             <a:r>
-              <a:rPr lang="en-US" smtClean="0"/>
+              <a:rPr lang="en-US"/>
               <a:t>Click to edit Master text styles</a:t>
             </a:r>
           </a:p>
@@ -2518,7 +2515,7 @@
             <a:fld id="{1D8BD707-D9CF-40AE-B4C6-C98DA3205C09}" type="datetimeFigureOut">
               <a:rPr lang="en-US" smtClean="0"/>
               <a:pPr/>
-              <a:t>8/1/2011</a:t>
+              <a:t>3/29/2026</a:t>
             </a:fld>
             <a:endParaRPr lang="en-US"/>
           </a:p>
@@ -2623,10 +2620,9 @@
           <a:lstStyle/>
           <a:p>
             <a:r>
-              <a:rPr lang="en-US" smtClean="0"/>
+              <a:rPr lang="en-US"/>
               <a:t>Click to edit Master title style</a:t>
             </a:r>
-            <a:endParaRPr lang="en-US"/>
           </a:p>
         </p:txBody>
       </p:sp>
@@ -2657,38 +2653,37 @@
           <a:p>
             <a:pPr lvl="0"/>
             <a:r>
-              <a:rPr lang="en-US" smtClean="0"/>
+              <a:rPr lang="en-US"/>
               <a:t>Click to edit Master text styles</a:t>
             </a:r>
           </a:p>
           <a:p>
             <a:pPr lvl="1"/>
             <a:r>
-              <a:rPr lang="en-US" smtClean="0"/>
+              <a:rPr lang="en-US"/>
               <a:t>Second level</a:t>
             </a:r>
           </a:p>
           <a:p>
             <a:pPr lvl="2"/>
             <a:r>
-              <a:rPr lang="en-US" smtClean="0"/>
+              <a:rPr lang="en-US"/>
               <a:t>Third level</a:t>
             </a:r>
           </a:p>
           <a:p>
             <a:pPr lvl="3"/>
             <a:r>
-              <a:rPr lang="en-US" smtClean="0"/>
+              <a:rPr lang="en-US"/>
               <a:t>Fourth level</a:t>
             </a:r>
           </a:p>
           <a:p>
             <a:pPr lvl="4"/>
             <a:r>
-              <a:rPr lang="en-US" smtClean="0"/>
+              <a:rPr lang="en-US"/>
               <a:t>Fifth level</a:t>
             </a:r>
-            <a:endParaRPr lang="en-US"/>
           </a:p>
         </p:txBody>
       </p:sp>
@@ -2728,7 +2723,7 @@
             <a:fld id="{1D8BD707-D9CF-40AE-B4C6-C98DA3205C09}" type="datetimeFigureOut">
               <a:rPr lang="en-US" smtClean="0"/>
               <a:pPr/>
-              <a:t>8/1/2011</a:t>
+              <a:t>3/29/2026</a:t>
             </a:fld>
             <a:endParaRPr lang="en-US"/>
           </a:p>
@@ -3083,13 +3078,14 @@
 </file>
 
 <file path=ppt/slides/slide1.xml><?xml version="1.0" encoding="utf-8"?>
-<p:sld xmlns:p="http://schemas.openxmlformats.org/presentationml/2006/main" xmlns:a="http://schemas.openxmlformats.org/drawingml/2006/main" xmlns:r="http://schemas.openxmlformats.org/officeDocument/2006/relationships">
+<p:sld xmlns:a="http://schemas.openxmlformats.org/drawingml/2006/main" xmlns:r="http://schemas.openxmlformats.org/officeDocument/2006/relationships" xmlns:p="http://schemas.openxmlformats.org/presentationml/2006/main">
   <p:cSld>
     <p:bg>
       <p:bgPr>
         <a:solidFill>
           <a:srgbClr val="F1F3F4"/>
         </a:solidFill>
+        <a:effectLst/>
       </p:bgPr>
     </p:bg>
     <p:spTree>
@@ -3108,12 +3104,12 @@
       </p:grpSpPr>
       <p:sp>
         <p:nvSpPr>
-          <p:cNvPr name="Freeform 2" id="2"/>
+          <p:cNvPr id="2" name="Freeform 2"/>
           <p:cNvSpPr/>
           <p:nvPr/>
         </p:nvSpPr>
         <p:spPr>
-          <a:xfrm flipH="false" flipV="false" rot="0">
+          <a:xfrm>
             <a:off x="0" y="0"/>
             <a:ext cx="3981926" cy="10287000"/>
           </a:xfrm>
@@ -3122,9 +3118,9 @@
             <a:gdLst/>
             <a:ahLst/>
             <a:cxnLst/>
-            <a:rect r="r" b="b" t="t" l="l"/>
+            <a:rect l="l" t="t" r="r" b="b"/>
             <a:pathLst>
-              <a:path h="10287000" w="3981926">
+              <a:path w="3981926" h="10287000">
                 <a:moveTo>
                   <a:pt x="0" y="0"/>
                 </a:moveTo>
@@ -3147,19 +3143,19 @@
           <a:blipFill>
             <a:blip r:embed="rId2"/>
             <a:stretch>
-              <a:fillRect l="0" t="0" r="0" b="0"/>
+              <a:fillRect/>
             </a:stretch>
           </a:blipFill>
         </p:spPr>
       </p:sp>
       <p:sp>
         <p:nvSpPr>
-          <p:cNvPr name="Freeform 3" id="3"/>
+          <p:cNvPr id="3" name="Freeform 3"/>
           <p:cNvSpPr/>
           <p:nvPr/>
         </p:nvSpPr>
         <p:spPr>
-          <a:xfrm flipH="false" flipV="false" rot="-885097">
+          <a:xfrm rot="-885097">
             <a:off x="11832225" y="-445677"/>
             <a:ext cx="10415786" cy="12060384"/>
           </a:xfrm>
@@ -3168,9 +3164,9 @@
             <a:gdLst/>
             <a:ahLst/>
             <a:cxnLst/>
-            <a:rect r="r" b="b" t="t" l="l"/>
+            <a:rect l="l" t="t" r="r" b="b"/>
             <a:pathLst>
-              <a:path h="12060384" w="10415786">
+              <a:path w="10415786" h="12060384">
                 <a:moveTo>
                   <a:pt x="0" y="0"/>
                 </a:moveTo>
@@ -3191,36 +3187,36 @@
             </a:pathLst>
           </a:custGeom>
           <a:blipFill>
-            <a:blip r:embed="rId3">
+            <a:blip>
               <a:extLst>
                 <a:ext uri="{96DAC541-7B7A-43D3-8B79-37D633B846F1}">
-                  <asvg:svgBlip xmlns:asvg="http://schemas.microsoft.com/office/drawing/2016/SVG/main" r:embed="rId4"/>
+                  <asvg:svgBlip xmlns:asvg="http://schemas.microsoft.com/office/drawing/2016/SVG/main" r:embed="rId3"/>
                 </a:ext>
               </a:extLst>
             </a:blip>
             <a:stretch>
-              <a:fillRect l="0" t="0" r="0" b="0"/>
+              <a:fillRect/>
             </a:stretch>
           </a:blipFill>
         </p:spPr>
       </p:sp>
       <p:sp>
         <p:nvSpPr>
-          <p:cNvPr name="TextBox 4" id="4"/>
-          <p:cNvSpPr txBox="true"/>
+          <p:cNvPr id="4" name="TextBox 4"/>
+          <p:cNvSpPr txBox="1"/>
           <p:nvPr/>
         </p:nvSpPr>
         <p:spPr>
-          <a:xfrm rot="0">
-            <a:off x="3529459" y="1741635"/>
-            <a:ext cx="11229082" cy="1285875"/>
+          <a:xfrm>
+            <a:off x="3529458" y="1741635"/>
+            <a:ext cx="11457797" cy="1235018"/>
           </a:xfrm>
           <a:prstGeom prst="rect">
             <a:avLst/>
           </a:prstGeom>
         </p:spPr>
         <p:txBody>
-          <a:bodyPr anchor="t" rtlCol="false" tIns="0" lIns="0" bIns="0" rIns="0">
+          <a:bodyPr wrap="square" lIns="0" tIns="0" rIns="0" bIns="0" rtlCol="0" anchor="t">
             <a:spAutoFit/>
           </a:bodyPr>
           <a:lstStyle/>
@@ -3231,7 +3227,7 @@
               </a:lnSpc>
             </a:pPr>
             <a:r>
-              <a:rPr lang="en-US" sz="7500">
+              <a:rPr lang="en-US" sz="7500" dirty="0">
                 <a:solidFill>
                   <a:srgbClr val="000000"/>
                 </a:solidFill>
@@ -3247,21 +3243,21 @@
       </p:sp>
       <p:sp>
         <p:nvSpPr>
-          <p:cNvPr name="TextBox 5" id="5"/>
-          <p:cNvSpPr txBox="true"/>
+          <p:cNvPr id="5" name="TextBox 5"/>
+          <p:cNvSpPr txBox="1"/>
           <p:nvPr/>
         </p:nvSpPr>
         <p:spPr>
-          <a:xfrm rot="0">
-            <a:off x="5167015" y="8398675"/>
-            <a:ext cx="7953970" cy="863600"/>
+          <a:xfrm>
+            <a:off x="5029200" y="8398675"/>
+            <a:ext cx="8091785" cy="823302"/>
           </a:xfrm>
           <a:prstGeom prst="rect">
             <a:avLst/>
           </a:prstGeom>
         </p:spPr>
         <p:txBody>
-          <a:bodyPr anchor="t" rtlCol="false" tIns="0" lIns="0" bIns="0" rIns="0">
+          <a:bodyPr wrap="square" lIns="0" tIns="0" rIns="0" bIns="0" rtlCol="0" anchor="t">
             <a:spAutoFit/>
           </a:bodyPr>
           <a:lstStyle/>
@@ -3272,7 +3268,7 @@
               </a:lnSpc>
             </a:pPr>
             <a:r>
-              <a:rPr lang="en-US" sz="5000">
+              <a:rPr lang="en-US" sz="5000" dirty="0">
                 <a:solidFill>
                   <a:srgbClr val="000000"/>
                 </a:solidFill>
@@ -3288,21 +3284,21 @@
       </p:sp>
       <p:sp>
         <p:nvSpPr>
-          <p:cNvPr name="TextBox 6" id="6"/>
-          <p:cNvSpPr txBox="true"/>
+          <p:cNvPr id="6" name="TextBox 6"/>
+          <p:cNvSpPr txBox="1"/>
           <p:nvPr/>
         </p:nvSpPr>
         <p:spPr>
-          <a:xfrm rot="0">
+          <a:xfrm>
             <a:off x="3300744" y="3475185"/>
-            <a:ext cx="11686512" cy="1835150"/>
+            <a:ext cx="11939256" cy="1885131"/>
           </a:xfrm>
           <a:prstGeom prst="rect">
             <a:avLst/>
           </a:prstGeom>
         </p:spPr>
         <p:txBody>
-          <a:bodyPr anchor="t" rtlCol="false" tIns="0" lIns="0" bIns="0" rIns="0">
+          <a:bodyPr wrap="square" lIns="0" tIns="0" rIns="0" bIns="0" rtlCol="0" anchor="t">
             <a:spAutoFit/>
           </a:bodyPr>
           <a:lstStyle/>
@@ -3313,7 +3309,7 @@
               </a:lnSpc>
             </a:pPr>
             <a:r>
-              <a:rPr lang="en-US" sz="3500">
+              <a:rPr lang="en-US" sz="3500" dirty="0">
                 <a:solidFill>
                   <a:srgbClr val="000000"/>
                 </a:solidFill>
@@ -3329,12 +3325,12 @@
       </p:sp>
       <p:sp>
         <p:nvSpPr>
-          <p:cNvPr name="TextBox 7" id="7"/>
-          <p:cNvSpPr txBox="true"/>
+          <p:cNvPr id="7" name="TextBox 7"/>
+          <p:cNvSpPr txBox="1"/>
           <p:nvPr/>
         </p:nvSpPr>
         <p:spPr>
-          <a:xfrm rot="0">
+          <a:xfrm>
             <a:off x="7333878" y="5754665"/>
             <a:ext cx="3620244" cy="2454275"/>
           </a:xfrm>
@@ -3343,7 +3339,7 @@
           </a:prstGeom>
         </p:spPr>
         <p:txBody>
-          <a:bodyPr anchor="t" rtlCol="false" tIns="0" lIns="0" bIns="0" rIns="0">
+          <a:bodyPr lIns="0" tIns="0" rIns="0" bIns="0" rtlCol="0" anchor="t">
             <a:spAutoFit/>
           </a:bodyPr>
           <a:lstStyle/>
@@ -3367,7 +3363,7 @@
             </a:r>
           </a:p>
           <a:p>
-            <a:pPr algn="l" marL="755651" indent="-377825" lvl="1">
+            <a:pPr marL="755651" lvl="1" indent="-377825" algn="l">
               <a:lnSpc>
                 <a:spcPts val="4900"/>
               </a:lnSpc>
@@ -3388,7 +3384,7 @@
             </a:r>
           </a:p>
           <a:p>
-            <a:pPr algn="l" marL="755651" indent="-377825" lvl="1">
+            <a:pPr marL="755651" lvl="1" indent="-377825" algn="l">
               <a:lnSpc>
                 <a:spcPts val="4900"/>
               </a:lnSpc>
@@ -3409,7 +3405,7 @@
             </a:r>
           </a:p>
           <a:p>
-            <a:pPr algn="l" marL="755651" indent="-377825" lvl="1">
+            <a:pPr marL="755651" lvl="1" indent="-377825" algn="l">
               <a:lnSpc>
                 <a:spcPts val="4900"/>
               </a:lnSpc>
@@ -3440,13 +3436,14 @@
 </file>
 
 <file path=ppt/slides/slide2.xml><?xml version="1.0" encoding="utf-8"?>
-<p:sld xmlns:p="http://schemas.openxmlformats.org/presentationml/2006/main" xmlns:a="http://schemas.openxmlformats.org/drawingml/2006/main" xmlns:r="http://schemas.openxmlformats.org/officeDocument/2006/relationships">
+<p:sld xmlns:a="http://schemas.openxmlformats.org/drawingml/2006/main" xmlns:r="http://schemas.openxmlformats.org/officeDocument/2006/relationships" xmlns:p="http://schemas.openxmlformats.org/presentationml/2006/main">
   <p:cSld>
     <p:bg>
       <p:bgPr>
         <a:solidFill>
           <a:srgbClr val="F1F3F4"/>
         </a:solidFill>
+        <a:effectLst/>
       </p:bgPr>
     </p:bg>
     <p:spTree>
@@ -3465,12 +3462,12 @@
       </p:grpSpPr>
       <p:sp>
         <p:nvSpPr>
-          <p:cNvPr name="Freeform 2" id="2"/>
+          <p:cNvPr id="2" name="Freeform 2"/>
           <p:cNvSpPr/>
           <p:nvPr/>
         </p:nvSpPr>
         <p:spPr>
-          <a:xfrm flipH="false" flipV="false" rot="0">
+          <a:xfrm>
             <a:off x="1028700" y="176985"/>
             <a:ext cx="16113745" cy="9933030"/>
           </a:xfrm>
@@ -3479,9 +3476,9 @@
             <a:gdLst/>
             <a:ahLst/>
             <a:cxnLst/>
-            <a:rect r="r" b="b" t="t" l="l"/>
+            <a:rect l="l" t="t" r="r" b="b"/>
             <a:pathLst>
-              <a:path h="9933030" w="16113745">
+              <a:path w="16113745" h="9933030">
                 <a:moveTo>
                   <a:pt x="0" y="0"/>
                 </a:moveTo>
@@ -3504,7 +3501,7 @@
           <a:blipFill>
             <a:blip r:embed="rId2"/>
             <a:stretch>
-              <a:fillRect l="0" t="0" r="-641" b="0"/>
+              <a:fillRect r="-641"/>
             </a:stretch>
           </a:blipFill>
         </p:spPr>
@@ -3518,13 +3515,14 @@
 </file>
 
 <file path=ppt/slides/slide3.xml><?xml version="1.0" encoding="utf-8"?>
-<p:sld xmlns:p="http://schemas.openxmlformats.org/presentationml/2006/main" xmlns:a="http://schemas.openxmlformats.org/drawingml/2006/main" xmlns:r="http://schemas.openxmlformats.org/officeDocument/2006/relationships">
+<p:sld xmlns:a="http://schemas.openxmlformats.org/drawingml/2006/main" xmlns:r="http://schemas.openxmlformats.org/officeDocument/2006/relationships" xmlns:p="http://schemas.openxmlformats.org/presentationml/2006/main">
   <p:cSld>
     <p:bg>
       <p:bgPr>
         <a:solidFill>
           <a:srgbClr val="F1F3F4"/>
         </a:solidFill>
+        <a:effectLst/>
       </p:bgPr>
     </p:bg>
     <p:spTree>
@@ -3543,12 +3541,12 @@
       </p:grpSpPr>
       <p:sp>
         <p:nvSpPr>
-          <p:cNvPr name="Freeform 2" id="2"/>
+          <p:cNvPr id="2" name="Freeform 2"/>
           <p:cNvSpPr/>
           <p:nvPr/>
         </p:nvSpPr>
         <p:spPr>
-          <a:xfrm flipH="false" flipV="false" rot="0">
+          <a:xfrm>
             <a:off x="399851" y="2067018"/>
             <a:ext cx="8516960" cy="7840015"/>
           </a:xfrm>
@@ -3557,9 +3555,9 @@
             <a:gdLst/>
             <a:ahLst/>
             <a:cxnLst/>
-            <a:rect r="r" b="b" t="t" l="l"/>
+            <a:rect l="l" t="t" r="r" b="b"/>
             <a:pathLst>
-              <a:path h="7840015" w="8516960">
+              <a:path w="8516960" h="7840015">
                 <a:moveTo>
                   <a:pt x="0" y="0"/>
                 </a:moveTo>
@@ -3582,19 +3580,19 @@
           <a:blipFill>
             <a:blip r:embed="rId2"/>
             <a:stretch>
-              <a:fillRect l="0" t="-152" r="-624" b="-552"/>
+              <a:fillRect t="-152" r="-624" b="-552"/>
             </a:stretch>
           </a:blipFill>
         </p:spPr>
       </p:sp>
       <p:sp>
         <p:nvSpPr>
-          <p:cNvPr name="TextBox 3" id="3"/>
-          <p:cNvSpPr txBox="true"/>
+          <p:cNvPr id="3" name="TextBox 3"/>
+          <p:cNvSpPr txBox="1"/>
           <p:nvPr/>
         </p:nvSpPr>
         <p:spPr>
-          <a:xfrm rot="0">
+          <a:xfrm>
             <a:off x="9144000" y="2009868"/>
             <a:ext cx="8759403" cy="7897165"/>
           </a:xfrm>
@@ -3603,7 +3601,7 @@
           </a:prstGeom>
         </p:spPr>
         <p:txBody>
-          <a:bodyPr anchor="t" rtlCol="false" tIns="0" lIns="0" bIns="0" rIns="0">
+          <a:bodyPr lIns="0" tIns="0" rIns="0" bIns="0" rtlCol="0" anchor="t">
             <a:spAutoFit/>
           </a:bodyPr>
           <a:lstStyle/>
@@ -3614,7 +3612,7 @@
               </a:lnSpc>
             </a:pPr>
             <a:r>
-              <a:rPr lang="en-US" sz="1992" b="true">
+              <a:rPr lang="en-US" sz="1992" b="1">
                 <a:solidFill>
                   <a:srgbClr val="004AAD"/>
                 </a:solidFill>
@@ -3633,7 +3631,7 @@
               </a:lnSpc>
             </a:pPr>
             <a:r>
-              <a:rPr lang="en-US" sz="1593" i="true" b="true">
+              <a:rPr lang="en-US" sz="1593" b="1" i="1">
                 <a:solidFill>
                   <a:srgbClr val="000000"/>
                 </a:solidFill>
@@ -3664,7 +3662,7 @@
               </a:lnSpc>
             </a:pPr>
             <a:r>
-              <a:rPr lang="en-US" sz="1593" i="true" b="true">
+              <a:rPr lang="en-US" sz="1593" b="1" i="1">
                 <a:solidFill>
                   <a:srgbClr val="000000"/>
                 </a:solidFill>
@@ -3695,7 +3693,7 @@
               </a:lnSpc>
             </a:pPr>
             <a:r>
-              <a:rPr lang="en-US" b="true" sz="1593" i="true">
+              <a:rPr lang="en-US" sz="1593" b="1" i="1">
                 <a:solidFill>
                   <a:srgbClr val="000000"/>
                 </a:solidFill>
@@ -3726,7 +3724,7 @@
               </a:lnSpc>
             </a:pPr>
             <a:r>
-              <a:rPr lang="en-US" b="true" sz="1593" i="true">
+              <a:rPr lang="en-US" sz="1593" b="1" i="1">
                 <a:solidFill>
                   <a:srgbClr val="000000"/>
                 </a:solidFill>
@@ -3756,6 +3754,15 @@
                 <a:spcPts val="2231"/>
               </a:lnSpc>
             </a:pPr>
+            <a:endParaRPr lang="en-US" sz="1593">
+              <a:solidFill>
+                <a:srgbClr val="000000"/>
+              </a:solidFill>
+              <a:latin typeface="Poppins"/>
+              <a:ea typeface="Poppins"/>
+              <a:cs typeface="Poppins"/>
+              <a:sym typeface="Poppins"/>
+            </a:endParaRPr>
           </a:p>
           <a:p>
             <a:pPr algn="l">
@@ -3764,7 +3771,7 @@
               </a:lnSpc>
             </a:pPr>
             <a:r>
-              <a:rPr lang="en-US" sz="1992" b="true">
+              <a:rPr lang="en-US" sz="1992" b="1">
                 <a:solidFill>
                   <a:srgbClr val="004AAD"/>
                 </a:solidFill>
@@ -3783,7 +3790,7 @@
               </a:lnSpc>
             </a:pPr>
             <a:r>
-              <a:rPr lang="en-US" b="true" sz="1594" i="true">
+              <a:rPr lang="en-US" sz="1594" b="1" i="1">
                 <a:solidFill>
                   <a:srgbClr val="000000"/>
                 </a:solidFill>
@@ -3813,6 +3820,15 @@
                 <a:spcPts val="2231"/>
               </a:lnSpc>
             </a:pPr>
+            <a:endParaRPr lang="en-US" sz="1594">
+              <a:solidFill>
+                <a:srgbClr val="000000"/>
+              </a:solidFill>
+              <a:latin typeface="Poppins"/>
+              <a:ea typeface="Poppins"/>
+              <a:cs typeface="Poppins"/>
+              <a:sym typeface="Poppins"/>
+            </a:endParaRPr>
           </a:p>
           <a:p>
             <a:pPr algn="l">
@@ -3821,7 +3837,7 @@
               </a:lnSpc>
             </a:pPr>
             <a:r>
-              <a:rPr lang="en-US" sz="1992" b="true">
+              <a:rPr lang="en-US" sz="1992" b="1">
                 <a:solidFill>
                   <a:srgbClr val="004AAD"/>
                 </a:solidFill>
@@ -3840,7 +3856,7 @@
               </a:lnSpc>
             </a:pPr>
             <a:r>
-              <a:rPr lang="en-US" b="true" sz="1594" i="true">
+              <a:rPr lang="en-US" sz="1594" b="1" i="1">
                 <a:solidFill>
                   <a:srgbClr val="000000"/>
                 </a:solidFill>
@@ -3871,7 +3887,7 @@
               </a:lnSpc>
             </a:pPr>
             <a:r>
-              <a:rPr lang="en-US" sz="1594" i="true" b="true">
+              <a:rPr lang="en-US" sz="1594" b="1" i="1">
                 <a:solidFill>
                   <a:srgbClr val="000000"/>
                 </a:solidFill>
@@ -3902,7 +3918,7 @@
               </a:lnSpc>
             </a:pPr>
             <a:r>
-              <a:rPr lang="en-US" sz="1594" i="true" b="true">
+              <a:rPr lang="en-US" sz="1594" b="1" i="1">
                 <a:solidFill>
                   <a:srgbClr val="000000"/>
                 </a:solidFill>
@@ -3932,6 +3948,15 @@
                 <a:spcPts val="2231"/>
               </a:lnSpc>
             </a:pPr>
+            <a:endParaRPr lang="en-US" sz="1594">
+              <a:solidFill>
+                <a:srgbClr val="000000"/>
+              </a:solidFill>
+              <a:latin typeface="Poppins"/>
+              <a:ea typeface="Poppins"/>
+              <a:cs typeface="Poppins"/>
+              <a:sym typeface="Poppins"/>
+            </a:endParaRPr>
           </a:p>
           <a:p>
             <a:pPr algn="l">
@@ -3940,7 +3965,7 @@
               </a:lnSpc>
             </a:pPr>
             <a:r>
-              <a:rPr lang="en-US" sz="1992" b="true">
+              <a:rPr lang="en-US" sz="1992" b="1">
                 <a:solidFill>
                   <a:srgbClr val="004AAD"/>
                 </a:solidFill>
@@ -3959,7 +3984,7 @@
               </a:lnSpc>
             </a:pPr>
             <a:r>
-              <a:rPr lang="en-US" sz="1594" i="true" b="true">
+              <a:rPr lang="en-US" sz="1594" b="1" i="1">
                 <a:solidFill>
                   <a:srgbClr val="000000"/>
                 </a:solidFill>
@@ -3989,6 +4014,15 @@
                 <a:spcPts val="2231"/>
               </a:lnSpc>
             </a:pPr>
+            <a:endParaRPr lang="en-US" sz="1594">
+              <a:solidFill>
+                <a:srgbClr val="000000"/>
+              </a:solidFill>
+              <a:latin typeface="Poppins"/>
+              <a:ea typeface="Poppins"/>
+              <a:cs typeface="Poppins"/>
+              <a:sym typeface="Poppins"/>
+            </a:endParaRPr>
           </a:p>
           <a:p>
             <a:pPr algn="l">
@@ -3997,7 +4031,7 @@
               </a:lnSpc>
             </a:pPr>
             <a:r>
-              <a:rPr lang="en-US" sz="1992" b="true">
+              <a:rPr lang="en-US" sz="1992" b="1">
                 <a:solidFill>
                   <a:srgbClr val="004AAD"/>
                 </a:solidFill>
@@ -4016,7 +4050,7 @@
               </a:lnSpc>
             </a:pPr>
             <a:r>
-              <a:rPr lang="en-US" sz="1594" i="true" b="true">
+              <a:rPr lang="en-US" sz="1594" b="1" i="1">
                 <a:solidFill>
                   <a:srgbClr val="000000"/>
                 </a:solidFill>
@@ -4046,6 +4080,15 @@
                 <a:spcPts val="2231"/>
               </a:lnSpc>
             </a:pPr>
+            <a:endParaRPr lang="en-US" sz="1594">
+              <a:solidFill>
+                <a:srgbClr val="000000"/>
+              </a:solidFill>
+              <a:latin typeface="Poppins"/>
+              <a:ea typeface="Poppins"/>
+              <a:cs typeface="Poppins"/>
+              <a:sym typeface="Poppins"/>
+            </a:endParaRPr>
           </a:p>
           <a:p>
             <a:pPr algn="l">
@@ -4054,7 +4097,7 @@
               </a:lnSpc>
             </a:pPr>
             <a:r>
-              <a:rPr lang="en-US" sz="1992" b="true">
+              <a:rPr lang="en-US" sz="1992" b="1">
                 <a:solidFill>
                   <a:srgbClr val="004AAD"/>
                 </a:solidFill>
@@ -4073,7 +4116,7 @@
               </a:lnSpc>
             </a:pPr>
             <a:r>
-              <a:rPr lang="en-US" sz="1594" i="true" b="true">
+              <a:rPr lang="en-US" sz="1594" b="1" i="1">
                 <a:solidFill>
                   <a:srgbClr val="000000"/>
                 </a:solidFill>
@@ -4101,7 +4144,7 @@
       </p:sp>
       <p:sp>
         <p:nvSpPr>
-          <p:cNvPr name="AutoShape 4" id="4"/>
+          <p:cNvPr id="4" name="AutoShape 4"/>
           <p:cNvSpPr/>
           <p:nvPr/>
         </p:nvSpPr>
@@ -4113,24 +4156,24 @@
           <a:prstGeom prst="line">
             <a:avLst/>
           </a:prstGeom>
-          <a:ln cap="flat" w="38100">
+          <a:ln w="38100" cap="flat">
             <a:solidFill>
               <a:srgbClr val="000000"/>
             </a:solidFill>
             <a:prstDash val="solid"/>
-            <a:headEnd type="none" len="sm" w="sm"/>
-            <a:tailEnd type="none" len="sm" w="sm"/>
+            <a:headEnd type="none" w="sm" len="sm"/>
+            <a:tailEnd type="none" w="sm" len="sm"/>
           </a:ln>
         </p:spPr>
       </p:sp>
       <p:sp>
         <p:nvSpPr>
-          <p:cNvPr name="TextBox 5" id="5"/>
-          <p:cNvSpPr txBox="true"/>
+          <p:cNvPr id="5" name="TextBox 5"/>
+          <p:cNvSpPr txBox="1"/>
           <p:nvPr/>
         </p:nvSpPr>
         <p:spPr>
-          <a:xfrm rot="0">
+          <a:xfrm>
             <a:off x="10106998" y="-168956"/>
             <a:ext cx="798705" cy="1197656"/>
           </a:xfrm>
@@ -4139,7 +4182,7 @@
           </a:prstGeom>
         </p:spPr>
         <p:txBody>
-          <a:bodyPr anchor="t" rtlCol="false" tIns="0" lIns="0" bIns="0" rIns="0">
+          <a:bodyPr lIns="0" tIns="0" rIns="0" bIns="0" rtlCol="0" anchor="t">
             <a:spAutoFit/>
           </a:bodyPr>
           <a:lstStyle/>
@@ -4150,7 +4193,7 @@
               </a:lnSpc>
             </a:pPr>
             <a:r>
-              <a:rPr lang="en-US" sz="6287" b="true">
+              <a:rPr lang="en-US" sz="6287" b="1">
                 <a:solidFill>
                   <a:srgbClr val="000000"/>
                 </a:solidFill>
@@ -4166,12 +4209,12 @@
       </p:sp>
       <p:sp>
         <p:nvSpPr>
-          <p:cNvPr name="TextBox 6" id="6"/>
-          <p:cNvSpPr txBox="true"/>
+          <p:cNvPr id="6" name="TextBox 6"/>
+          <p:cNvSpPr txBox="1"/>
           <p:nvPr/>
         </p:nvSpPr>
         <p:spPr>
-          <a:xfrm rot="0">
+          <a:xfrm>
             <a:off x="465967" y="690209"/>
             <a:ext cx="8384728" cy="1376809"/>
           </a:xfrm>
@@ -4180,7 +4223,7 @@
           </a:prstGeom>
         </p:spPr>
         <p:txBody>
-          <a:bodyPr anchor="t" rtlCol="false" tIns="0" lIns="0" bIns="0" rIns="0">
+          <a:bodyPr lIns="0" tIns="0" rIns="0" bIns="0" rtlCol="0" anchor="t">
             <a:spAutoFit/>
           </a:bodyPr>
           <a:lstStyle/>
@@ -4191,7 +4234,7 @@
               </a:lnSpc>
             </a:pPr>
             <a:r>
-              <a:rPr lang="en-US" b="true" sz="8074">
+              <a:rPr lang="en-US" sz="8074" b="1">
                 <a:solidFill>
                   <a:srgbClr val="00325A"/>
                 </a:solidFill>
@@ -4214,13 +4257,14 @@
 </file>
 
 <file path=ppt/slides/slide4.xml><?xml version="1.0" encoding="utf-8"?>
-<p:sld xmlns:p="http://schemas.openxmlformats.org/presentationml/2006/main" xmlns:a="http://schemas.openxmlformats.org/drawingml/2006/main" xmlns:r="http://schemas.openxmlformats.org/officeDocument/2006/relationships">
+<p:sld xmlns:a="http://schemas.openxmlformats.org/drawingml/2006/main" xmlns:r="http://schemas.openxmlformats.org/officeDocument/2006/relationships" xmlns:p="http://schemas.openxmlformats.org/presentationml/2006/main">
   <p:cSld>
     <p:bg>
       <p:bgPr>
         <a:solidFill>
           <a:srgbClr val="F1F3F4"/>
         </a:solidFill>
+        <a:effectLst/>
       </p:bgPr>
     </p:bg>
     <p:spTree>
@@ -4239,12 +4283,12 @@
       </p:grpSpPr>
       <p:sp>
         <p:nvSpPr>
-          <p:cNvPr name="Freeform 2" id="2"/>
+          <p:cNvPr id="2" name="Freeform 2"/>
           <p:cNvSpPr/>
           <p:nvPr/>
         </p:nvSpPr>
         <p:spPr>
-          <a:xfrm flipH="false" flipV="false" rot="-883051">
+          <a:xfrm rot="-883051">
             <a:off x="11093067" y="-872901"/>
             <a:ext cx="10750098" cy="12447482"/>
           </a:xfrm>
@@ -4253,9 +4297,9 @@
             <a:gdLst/>
             <a:ahLst/>
             <a:cxnLst/>
-            <a:rect r="r" b="b" t="t" l="l"/>
+            <a:rect l="l" t="t" r="r" b="b"/>
             <a:pathLst>
-              <a:path h="12447482" w="10750098">
+              <a:path w="10750098" h="12447482">
                 <a:moveTo>
                   <a:pt x="0" y="0"/>
                 </a:moveTo>
@@ -4276,22 +4320,22 @@
             </a:pathLst>
           </a:custGeom>
           <a:blipFill>
-            <a:blip r:embed="rId2">
+            <a:blip>
               <a:extLst>
                 <a:ext uri="{96DAC541-7B7A-43D3-8B79-37D633B846F1}">
-                  <asvg:svgBlip xmlns:asvg="http://schemas.microsoft.com/office/drawing/2016/SVG/main" r:embed="rId3"/>
+                  <asvg:svgBlip xmlns:asvg="http://schemas.microsoft.com/office/drawing/2016/SVG/main" r:embed="rId2"/>
                 </a:ext>
               </a:extLst>
             </a:blip>
             <a:stretch>
-              <a:fillRect l="0" t="0" r="0" b="0"/>
+              <a:fillRect/>
             </a:stretch>
           </a:blipFill>
         </p:spPr>
       </p:sp>
       <p:sp>
         <p:nvSpPr>
-          <p:cNvPr name="AutoShape 3" id="3"/>
+          <p:cNvPr id="3" name="AutoShape 3"/>
           <p:cNvSpPr/>
           <p:nvPr/>
         </p:nvSpPr>
@@ -4303,24 +4347,24 @@
           <a:prstGeom prst="line">
             <a:avLst/>
           </a:prstGeom>
-          <a:ln cap="flat" w="38100">
+          <a:ln w="38100" cap="flat">
             <a:solidFill>
               <a:srgbClr val="000000"/>
             </a:solidFill>
             <a:prstDash val="solid"/>
-            <a:headEnd type="none" len="sm" w="sm"/>
-            <a:tailEnd type="none" len="sm" w="sm"/>
+            <a:headEnd type="none" w="sm" len="sm"/>
+            <a:tailEnd type="none" w="sm" len="sm"/>
           </a:ln>
         </p:spPr>
       </p:sp>
       <p:sp>
         <p:nvSpPr>
-          <p:cNvPr name="TextBox 4" id="4"/>
-          <p:cNvSpPr txBox="true"/>
+          <p:cNvPr id="4" name="TextBox 4"/>
+          <p:cNvSpPr txBox="1"/>
           <p:nvPr/>
         </p:nvSpPr>
         <p:spPr>
-          <a:xfrm rot="0">
+          <a:xfrm>
             <a:off x="385791" y="664542"/>
             <a:ext cx="8107814" cy="1376809"/>
           </a:xfrm>
@@ -4329,7 +4373,7 @@
           </a:prstGeom>
         </p:spPr>
         <p:txBody>
-          <a:bodyPr anchor="t" rtlCol="false" tIns="0" lIns="0" bIns="0" rIns="0">
+          <a:bodyPr lIns="0" tIns="0" rIns="0" bIns="0" rtlCol="0" anchor="t">
             <a:spAutoFit/>
           </a:bodyPr>
           <a:lstStyle/>
@@ -4340,7 +4384,7 @@
               </a:lnSpc>
             </a:pPr>
             <a:r>
-              <a:rPr lang="en-US" b="true" sz="8074">
+              <a:rPr lang="en-US" sz="8074" b="1">
                 <a:solidFill>
                   <a:srgbClr val="00325A"/>
                 </a:solidFill>
@@ -4356,12 +4400,12 @@
       </p:sp>
       <p:sp>
         <p:nvSpPr>
-          <p:cNvPr name="TextBox 5" id="5"/>
-          <p:cNvSpPr txBox="true"/>
+          <p:cNvPr id="5" name="TextBox 5"/>
+          <p:cNvSpPr txBox="1"/>
           <p:nvPr/>
         </p:nvSpPr>
         <p:spPr>
-          <a:xfrm rot="0">
+          <a:xfrm>
             <a:off x="385791" y="2350946"/>
             <a:ext cx="10625430" cy="5859145"/>
           </a:xfrm>
@@ -4370,12 +4414,12 @@
           </a:prstGeom>
         </p:spPr>
         <p:txBody>
-          <a:bodyPr anchor="t" rtlCol="false" tIns="0" lIns="0" bIns="0" rIns="0">
+          <a:bodyPr lIns="0" tIns="0" rIns="0" bIns="0" rtlCol="0" anchor="t">
             <a:spAutoFit/>
           </a:bodyPr>
           <a:lstStyle/>
           <a:p>
-            <a:pPr algn="l" marL="474979" indent="-237490" lvl="1">
+            <a:pPr marL="474979" lvl="1" indent="-237490" algn="l">
               <a:lnSpc>
                 <a:spcPts val="3079"/>
               </a:lnSpc>
@@ -4383,7 +4427,7 @@
               <a:buChar char="•"/>
             </a:pPr>
             <a:r>
-              <a:rPr lang="en-US" b="true" sz="2199">
+              <a:rPr lang="en-US" sz="2199" b="1">
                 <a:solidFill>
                   <a:srgbClr val="000000"/>
                 </a:solidFill>
@@ -4408,7 +4452,7 @@
             </a:r>
           </a:p>
           <a:p>
-            <a:pPr algn="l" marL="474979" indent="-237490" lvl="1">
+            <a:pPr marL="474979" lvl="1" indent="-237490" algn="l">
               <a:lnSpc>
                 <a:spcPts val="3079"/>
               </a:lnSpc>
@@ -4416,7 +4460,7 @@
               <a:buChar char="•"/>
             </a:pPr>
             <a:r>
-              <a:rPr lang="en-US" b="true" sz="2199">
+              <a:rPr lang="en-US" sz="2199" b="1">
                 <a:solidFill>
                   <a:srgbClr val="000000"/>
                 </a:solidFill>
@@ -4441,7 +4485,7 @@
             </a:r>
           </a:p>
           <a:p>
-            <a:pPr algn="l" marL="474979" indent="-237490" lvl="1">
+            <a:pPr marL="474979" lvl="1" indent="-237490" algn="l">
               <a:lnSpc>
                 <a:spcPts val="3079"/>
               </a:lnSpc>
@@ -4449,7 +4493,7 @@
               <a:buChar char="•"/>
             </a:pPr>
             <a:r>
-              <a:rPr lang="en-US" b="true" sz="2199">
+              <a:rPr lang="en-US" sz="2199" b="1">
                 <a:solidFill>
                   <a:srgbClr val="000000"/>
                 </a:solidFill>
@@ -4474,7 +4518,7 @@
             </a:r>
           </a:p>
           <a:p>
-            <a:pPr algn="l" marL="474979" indent="-237490" lvl="1">
+            <a:pPr marL="474979" lvl="1" indent="-237490" algn="l">
               <a:lnSpc>
                 <a:spcPts val="3079"/>
               </a:lnSpc>
@@ -4482,7 +4526,7 @@
               <a:buChar char="•"/>
             </a:pPr>
             <a:r>
-              <a:rPr lang="en-US" b="true" sz="2199">
+              <a:rPr lang="en-US" sz="2199" b="1">
                 <a:solidFill>
                   <a:srgbClr val="000000"/>
                 </a:solidFill>
@@ -4507,7 +4551,7 @@
             </a:r>
           </a:p>
           <a:p>
-            <a:pPr algn="l" marL="474979" indent="-237490" lvl="1">
+            <a:pPr marL="474979" lvl="1" indent="-237490" algn="l">
               <a:lnSpc>
                 <a:spcPts val="3079"/>
               </a:lnSpc>
@@ -4515,7 +4559,7 @@
               <a:buChar char="•"/>
             </a:pPr>
             <a:r>
-              <a:rPr lang="en-US" b="true" sz="2199">
+              <a:rPr lang="en-US" sz="2199" b="1">
                 <a:solidFill>
                   <a:srgbClr val="000000"/>
                 </a:solidFill>
@@ -4540,7 +4584,7 @@
             </a:r>
           </a:p>
           <a:p>
-            <a:pPr algn="l" marL="474979" indent="-237490" lvl="1">
+            <a:pPr marL="474979" lvl="1" indent="-237490" algn="l">
               <a:lnSpc>
                 <a:spcPts val="3079"/>
               </a:lnSpc>
@@ -4548,7 +4592,7 @@
               <a:buChar char="•"/>
             </a:pPr>
             <a:r>
-              <a:rPr lang="en-US" b="true" sz="2199">
+              <a:rPr lang="en-US" sz="2199" b="1">
                 <a:solidFill>
                   <a:srgbClr val="000000"/>
                 </a:solidFill>
@@ -4576,12 +4620,12 @@
       </p:sp>
       <p:sp>
         <p:nvSpPr>
-          <p:cNvPr name="TextBox 6" id="6"/>
-          <p:cNvSpPr txBox="true"/>
+          <p:cNvPr id="6" name="TextBox 6"/>
+          <p:cNvSpPr txBox="1"/>
           <p:nvPr/>
         </p:nvSpPr>
         <p:spPr>
-          <a:xfrm rot="0">
+          <a:xfrm>
             <a:off x="10106998" y="-168956"/>
             <a:ext cx="798705" cy="1197656"/>
           </a:xfrm>
@@ -4590,7 +4634,7 @@
           </a:prstGeom>
         </p:spPr>
         <p:txBody>
-          <a:bodyPr anchor="t" rtlCol="false" tIns="0" lIns="0" bIns="0" rIns="0">
+          <a:bodyPr lIns="0" tIns="0" rIns="0" bIns="0" rtlCol="0" anchor="t">
             <a:spAutoFit/>
           </a:bodyPr>
           <a:lstStyle/>
@@ -4601,7 +4645,7 @@
               </a:lnSpc>
             </a:pPr>
             <a:r>
-              <a:rPr lang="en-US" sz="6287" b="true">
+              <a:rPr lang="en-US" sz="6287" b="1">
                 <a:solidFill>
                   <a:srgbClr val="000000"/>
                 </a:solidFill>
@@ -4624,13 +4668,14 @@
 </file>
 
 <file path=ppt/slides/slide5.xml><?xml version="1.0" encoding="utf-8"?>
-<p:sld xmlns:p="http://schemas.openxmlformats.org/presentationml/2006/main" xmlns:a="http://schemas.openxmlformats.org/drawingml/2006/main" xmlns:r="http://schemas.openxmlformats.org/officeDocument/2006/relationships">
+<p:sld xmlns:a="http://schemas.openxmlformats.org/drawingml/2006/main" xmlns:r="http://schemas.openxmlformats.org/officeDocument/2006/relationships" xmlns:p="http://schemas.openxmlformats.org/presentationml/2006/main">
   <p:cSld>
     <p:bg>
       <p:bgPr>
         <a:solidFill>
           <a:srgbClr val="F1F3F4"/>
         </a:solidFill>
+        <a:effectLst/>
       </p:bgPr>
     </p:bg>
     <p:spTree>
@@ -4649,7 +4694,7 @@
       </p:grpSpPr>
       <p:sp>
         <p:nvSpPr>
-          <p:cNvPr name="AutoShape 2" id="2"/>
+          <p:cNvPr id="2" name="AutoShape 2"/>
           <p:cNvSpPr/>
           <p:nvPr/>
         </p:nvSpPr>
@@ -4661,24 +4706,24 @@
           <a:prstGeom prst="line">
             <a:avLst/>
           </a:prstGeom>
-          <a:ln cap="flat" w="38100">
+          <a:ln w="38100" cap="flat">
             <a:solidFill>
               <a:srgbClr val="000000"/>
             </a:solidFill>
             <a:prstDash val="solid"/>
-            <a:headEnd type="none" len="sm" w="sm"/>
-            <a:tailEnd type="none" len="sm" w="sm"/>
+            <a:headEnd type="none" w="sm" len="sm"/>
+            <a:tailEnd type="none" w="sm" len="sm"/>
           </a:ln>
         </p:spPr>
       </p:sp>
       <p:sp>
         <p:nvSpPr>
-          <p:cNvPr name="Freeform 3" id="3"/>
+          <p:cNvPr id="3" name="Freeform 3"/>
           <p:cNvSpPr/>
           <p:nvPr/>
         </p:nvSpPr>
         <p:spPr>
-          <a:xfrm flipH="false" flipV="false" rot="0">
+          <a:xfrm>
             <a:off x="507901" y="2905427"/>
             <a:ext cx="8396529" cy="3127707"/>
           </a:xfrm>
@@ -4687,9 +4732,9 @@
             <a:gdLst/>
             <a:ahLst/>
             <a:cxnLst/>
-            <a:rect r="r" b="b" t="t" l="l"/>
+            <a:rect l="l" t="t" r="r" b="b"/>
             <a:pathLst>
-              <a:path h="3127707" w="8396529">
+              <a:path w="8396529" h="3127707">
                 <a:moveTo>
                   <a:pt x="0" y="0"/>
                 </a:moveTo>
@@ -4712,19 +4757,19 @@
           <a:blipFill>
             <a:blip r:embed="rId2"/>
             <a:stretch>
-              <a:fillRect l="0" t="0" r="0" b="0"/>
+              <a:fillRect/>
             </a:stretch>
           </a:blipFill>
         </p:spPr>
       </p:sp>
       <p:sp>
         <p:nvSpPr>
-          <p:cNvPr name="Freeform 4" id="4"/>
+          <p:cNvPr id="4" name="Freeform 4"/>
           <p:cNvSpPr/>
           <p:nvPr/>
         </p:nvSpPr>
         <p:spPr>
-          <a:xfrm flipH="false" flipV="false" rot="0">
+          <a:xfrm>
             <a:off x="9351552" y="2905427"/>
             <a:ext cx="7061036" cy="3127707"/>
           </a:xfrm>
@@ -4733,9 +4778,9 @@
             <a:gdLst/>
             <a:ahLst/>
             <a:cxnLst/>
-            <a:rect r="r" b="b" t="t" l="l"/>
+            <a:rect l="l" t="t" r="r" b="b"/>
             <a:pathLst>
-              <a:path h="3127707" w="7061036">
+              <a:path w="7061036" h="3127707">
                 <a:moveTo>
                   <a:pt x="0" y="0"/>
                 </a:moveTo>
@@ -4758,19 +4803,19 @@
           <a:blipFill>
             <a:blip r:embed="rId3"/>
             <a:stretch>
-              <a:fillRect l="0" t="0" r="0" b="0"/>
+              <a:fillRect/>
             </a:stretch>
           </a:blipFill>
         </p:spPr>
       </p:sp>
       <p:sp>
         <p:nvSpPr>
-          <p:cNvPr name="Freeform 5" id="5"/>
+          <p:cNvPr id="5" name="Freeform 5"/>
           <p:cNvSpPr/>
           <p:nvPr/>
         </p:nvSpPr>
         <p:spPr>
-          <a:xfrm flipH="false" flipV="false" rot="0">
+          <a:xfrm>
             <a:off x="5563873" y="6773309"/>
             <a:ext cx="8396529" cy="3127707"/>
           </a:xfrm>
@@ -4779,9 +4824,9 @@
             <a:gdLst/>
             <a:ahLst/>
             <a:cxnLst/>
-            <a:rect r="r" b="b" t="t" l="l"/>
+            <a:rect l="l" t="t" r="r" b="b"/>
             <a:pathLst>
-              <a:path h="3127707" w="8396529">
+              <a:path w="8396529" h="3127707">
                 <a:moveTo>
                   <a:pt x="0" y="0"/>
                 </a:moveTo>
@@ -4804,19 +4849,19 @@
           <a:blipFill>
             <a:blip r:embed="rId2"/>
             <a:stretch>
-              <a:fillRect l="0" t="0" r="0" b="0"/>
+              <a:fillRect/>
             </a:stretch>
           </a:blipFill>
         </p:spPr>
       </p:sp>
       <p:sp>
         <p:nvSpPr>
-          <p:cNvPr name="TextBox 6" id="6"/>
-          <p:cNvSpPr txBox="true"/>
+          <p:cNvPr id="6" name="TextBox 6"/>
+          <p:cNvSpPr txBox="1"/>
           <p:nvPr/>
         </p:nvSpPr>
         <p:spPr>
-          <a:xfrm rot="0">
+          <a:xfrm>
             <a:off x="507901" y="633608"/>
             <a:ext cx="12407106" cy="1376809"/>
           </a:xfrm>
@@ -4825,7 +4870,7 @@
           </a:prstGeom>
         </p:spPr>
         <p:txBody>
-          <a:bodyPr anchor="t" rtlCol="false" tIns="0" lIns="0" bIns="0" rIns="0">
+          <a:bodyPr lIns="0" tIns="0" rIns="0" bIns="0" rtlCol="0" anchor="t">
             <a:spAutoFit/>
           </a:bodyPr>
           <a:lstStyle/>
@@ -4836,7 +4881,7 @@
               </a:lnSpc>
             </a:pPr>
             <a:r>
-              <a:rPr lang="en-US" b="true" sz="8074">
+              <a:rPr lang="en-US" sz="8074" b="1">
                 <a:solidFill>
                   <a:srgbClr val="00325A"/>
                 </a:solidFill>
@@ -4852,12 +4897,12 @@
       </p:sp>
       <p:sp>
         <p:nvSpPr>
-          <p:cNvPr name="TextBox 7" id="7"/>
-          <p:cNvSpPr txBox="true"/>
+          <p:cNvPr id="7" name="TextBox 7"/>
+          <p:cNvSpPr txBox="1"/>
           <p:nvPr/>
         </p:nvSpPr>
         <p:spPr>
-          <a:xfrm rot="0">
+          <a:xfrm>
             <a:off x="10106998" y="-168956"/>
             <a:ext cx="798705" cy="1197656"/>
           </a:xfrm>
@@ -4866,7 +4911,7 @@
           </a:prstGeom>
         </p:spPr>
         <p:txBody>
-          <a:bodyPr anchor="t" rtlCol="false" tIns="0" lIns="0" bIns="0" rIns="0">
+          <a:bodyPr lIns="0" tIns="0" rIns="0" bIns="0" rtlCol="0" anchor="t">
             <a:spAutoFit/>
           </a:bodyPr>
           <a:lstStyle/>
@@ -4877,7 +4922,7 @@
               </a:lnSpc>
             </a:pPr>
             <a:r>
-              <a:rPr lang="en-US" sz="6287" b="true">
+              <a:rPr lang="en-US" sz="6287" b="1">
                 <a:solidFill>
                   <a:srgbClr val="000000"/>
                 </a:solidFill>
@@ -4893,12 +4938,12 @@
       </p:sp>
       <p:sp>
         <p:nvSpPr>
-          <p:cNvPr name="TextBox 8" id="8"/>
-          <p:cNvSpPr txBox="true"/>
+          <p:cNvPr id="8" name="TextBox 8"/>
+          <p:cNvSpPr txBox="1"/>
           <p:nvPr/>
         </p:nvSpPr>
         <p:spPr>
-          <a:xfrm rot="0">
+          <a:xfrm>
             <a:off x="507901" y="2279551"/>
             <a:ext cx="8396529" cy="441325"/>
           </a:xfrm>
@@ -4907,7 +4952,7 @@
           </a:prstGeom>
         </p:spPr>
         <p:txBody>
-          <a:bodyPr anchor="t" rtlCol="false" tIns="0" lIns="0" bIns="0" rIns="0">
+          <a:bodyPr lIns="0" tIns="0" rIns="0" bIns="0" rtlCol="0" anchor="t">
             <a:spAutoFit/>
           </a:bodyPr>
           <a:lstStyle/>
@@ -4934,12 +4979,12 @@
       </p:sp>
       <p:sp>
         <p:nvSpPr>
-          <p:cNvPr name="TextBox 9" id="9"/>
-          <p:cNvSpPr txBox="true"/>
+          <p:cNvPr id="9" name="TextBox 9"/>
+          <p:cNvSpPr txBox="1"/>
           <p:nvPr/>
         </p:nvSpPr>
         <p:spPr>
-          <a:xfrm rot="0">
+          <a:xfrm>
             <a:off x="9351552" y="2279551"/>
             <a:ext cx="8396529" cy="441325"/>
           </a:xfrm>
@@ -4948,7 +4993,7 @@
           </a:prstGeom>
         </p:spPr>
         <p:txBody>
-          <a:bodyPr anchor="t" rtlCol="false" tIns="0" lIns="0" bIns="0" rIns="0">
+          <a:bodyPr lIns="0" tIns="0" rIns="0" bIns="0" rtlCol="0" anchor="t">
             <a:spAutoFit/>
           </a:bodyPr>
           <a:lstStyle/>
@@ -4975,12 +5020,12 @@
       </p:sp>
       <p:sp>
         <p:nvSpPr>
-          <p:cNvPr name="TextBox 10" id="10"/>
-          <p:cNvSpPr txBox="true"/>
+          <p:cNvPr id="10" name="TextBox 10"/>
+          <p:cNvSpPr txBox="1"/>
           <p:nvPr/>
         </p:nvSpPr>
         <p:spPr>
-          <a:xfrm rot="0">
+          <a:xfrm>
             <a:off x="5563873" y="6147434"/>
             <a:ext cx="8396529" cy="441325"/>
           </a:xfrm>
@@ -4989,7 +5034,7 @@
           </a:prstGeom>
         </p:spPr>
         <p:txBody>
-          <a:bodyPr anchor="t" rtlCol="false" tIns="0" lIns="0" bIns="0" rIns="0">
+          <a:bodyPr lIns="0" tIns="0" rIns="0" bIns="0" rtlCol="0" anchor="t">
             <a:spAutoFit/>
           </a:bodyPr>
           <a:lstStyle/>
@@ -5023,13 +5068,14 @@
 </file>
 
 <file path=ppt/slides/slide6.xml><?xml version="1.0" encoding="utf-8"?>
-<p:sld xmlns:p="http://schemas.openxmlformats.org/presentationml/2006/main" xmlns:a="http://schemas.openxmlformats.org/drawingml/2006/main" xmlns:r="http://schemas.openxmlformats.org/officeDocument/2006/relationships">
+<p:sld xmlns:a="http://schemas.openxmlformats.org/drawingml/2006/main" xmlns:r="http://schemas.openxmlformats.org/officeDocument/2006/relationships" xmlns:p="http://schemas.openxmlformats.org/presentationml/2006/main">
   <p:cSld>
     <p:bg>
       <p:bgPr>
         <a:solidFill>
           <a:srgbClr val="F1F3F4"/>
         </a:solidFill>
+        <a:effectLst/>
       </p:bgPr>
     </p:bg>
     <p:spTree>
@@ -5048,7 +5094,7 @@
       </p:grpSpPr>
       <p:sp>
         <p:nvSpPr>
-          <p:cNvPr name="AutoShape 2" id="2"/>
+          <p:cNvPr id="2" name="AutoShape 2"/>
           <p:cNvSpPr/>
           <p:nvPr/>
         </p:nvSpPr>
@@ -5060,24 +5106,24 @@
           <a:prstGeom prst="line">
             <a:avLst/>
           </a:prstGeom>
-          <a:ln cap="flat" w="38100">
+          <a:ln w="38100" cap="flat">
             <a:solidFill>
               <a:srgbClr val="000000"/>
             </a:solidFill>
             <a:prstDash val="solid"/>
-            <a:headEnd type="none" len="sm" w="sm"/>
-            <a:tailEnd type="none" len="sm" w="sm"/>
+            <a:headEnd type="none" w="sm" len="sm"/>
+            <a:tailEnd type="none" w="sm" len="sm"/>
           </a:ln>
         </p:spPr>
       </p:sp>
       <p:sp>
         <p:nvSpPr>
-          <p:cNvPr name="Freeform 3" id="3"/>
+          <p:cNvPr id="3" name="Freeform 3"/>
           <p:cNvSpPr/>
           <p:nvPr/>
         </p:nvSpPr>
         <p:spPr>
-          <a:xfrm flipH="false" flipV="false" rot="0">
+          <a:xfrm>
             <a:off x="673463" y="2533033"/>
             <a:ext cx="7405579" cy="5220933"/>
           </a:xfrm>
@@ -5086,9 +5132,9 @@
             <a:gdLst/>
             <a:ahLst/>
             <a:cxnLst/>
-            <a:rect r="r" b="b" t="t" l="l"/>
+            <a:rect l="l" t="t" r="r" b="b"/>
             <a:pathLst>
-              <a:path h="5220933" w="7405579">
+              <a:path w="7405579" h="5220933">
                 <a:moveTo>
                   <a:pt x="0" y="0"/>
                 </a:moveTo>
@@ -5111,19 +5157,19 @@
           <a:blipFill>
             <a:blip r:embed="rId2"/>
             <a:stretch>
-              <a:fillRect l="0" t="0" r="0" b="0"/>
+              <a:fillRect/>
             </a:stretch>
           </a:blipFill>
         </p:spPr>
       </p:sp>
       <p:sp>
         <p:nvSpPr>
-          <p:cNvPr name="Freeform 4" id="4"/>
+          <p:cNvPr id="4" name="Freeform 4"/>
           <p:cNvSpPr/>
           <p:nvPr/>
         </p:nvSpPr>
         <p:spPr>
-          <a:xfrm flipH="false" flipV="false" rot="0">
+          <a:xfrm>
             <a:off x="8875899" y="1640905"/>
             <a:ext cx="8383401" cy="3739984"/>
           </a:xfrm>
@@ -5132,9 +5178,9 @@
             <a:gdLst/>
             <a:ahLst/>
             <a:cxnLst/>
-            <a:rect r="r" b="b" t="t" l="l"/>
+            <a:rect l="l" t="t" r="r" b="b"/>
             <a:pathLst>
-              <a:path h="3739984" w="8383401">
+              <a:path w="8383401" h="3739984">
                 <a:moveTo>
                   <a:pt x="0" y="0"/>
                 </a:moveTo>
@@ -5157,19 +5203,19 @@
           <a:blipFill>
             <a:blip r:embed="rId3"/>
             <a:stretch>
-              <a:fillRect l="0" t="0" r="0" b="-57749"/>
+              <a:fillRect b="-57749"/>
             </a:stretch>
           </a:blipFill>
         </p:spPr>
       </p:sp>
       <p:sp>
         <p:nvSpPr>
-          <p:cNvPr name="Freeform 5" id="5"/>
+          <p:cNvPr id="5" name="Freeform 5"/>
           <p:cNvSpPr/>
           <p:nvPr/>
         </p:nvSpPr>
         <p:spPr>
-          <a:xfrm flipH="false" flipV="false" rot="0">
+          <a:xfrm>
             <a:off x="8875899" y="5990489"/>
             <a:ext cx="8383401" cy="3772718"/>
           </a:xfrm>
@@ -5178,9 +5224,9 @@
             <a:gdLst/>
             <a:ahLst/>
             <a:cxnLst/>
-            <a:rect r="r" b="b" t="t" l="l"/>
+            <a:rect l="l" t="t" r="r" b="b"/>
             <a:pathLst>
-              <a:path h="3772718" w="8383401">
+              <a:path w="8383401" h="3772718">
                 <a:moveTo>
                   <a:pt x="0" y="0"/>
                 </a:moveTo>
@@ -5203,19 +5249,19 @@
           <a:blipFill>
             <a:blip r:embed="rId4"/>
             <a:stretch>
-              <a:fillRect l="0" t="0" r="0" b="-56103"/>
+              <a:fillRect b="-56103"/>
             </a:stretch>
           </a:blipFill>
         </p:spPr>
       </p:sp>
       <p:sp>
         <p:nvSpPr>
-          <p:cNvPr name="TextBox 6" id="6"/>
-          <p:cNvSpPr txBox="true"/>
+          <p:cNvPr id="6" name="TextBox 6"/>
+          <p:cNvSpPr txBox="1"/>
           <p:nvPr/>
         </p:nvSpPr>
         <p:spPr>
-          <a:xfrm rot="0">
+          <a:xfrm>
             <a:off x="673463" y="727011"/>
             <a:ext cx="5625390" cy="1376809"/>
           </a:xfrm>
@@ -5224,7 +5270,7 @@
           </a:prstGeom>
         </p:spPr>
         <p:txBody>
-          <a:bodyPr anchor="t" rtlCol="false" tIns="0" lIns="0" bIns="0" rIns="0">
+          <a:bodyPr lIns="0" tIns="0" rIns="0" bIns="0" rtlCol="0" anchor="t">
             <a:spAutoFit/>
           </a:bodyPr>
           <a:lstStyle/>
@@ -5235,7 +5281,7 @@
               </a:lnSpc>
             </a:pPr>
             <a:r>
-              <a:rPr lang="en-US" b="true" sz="8074">
+              <a:rPr lang="en-US" sz="8074" b="1">
                 <a:solidFill>
                   <a:srgbClr val="00325A"/>
                 </a:solidFill>
@@ -5251,12 +5297,12 @@
       </p:sp>
       <p:sp>
         <p:nvSpPr>
-          <p:cNvPr name="TextBox 7" id="7"/>
-          <p:cNvSpPr txBox="true"/>
+          <p:cNvPr id="7" name="TextBox 7"/>
+          <p:cNvSpPr txBox="1"/>
           <p:nvPr/>
         </p:nvSpPr>
         <p:spPr>
-          <a:xfrm rot="0">
+          <a:xfrm>
             <a:off x="10106998" y="-168956"/>
             <a:ext cx="798705" cy="1197656"/>
           </a:xfrm>
@@ -5265,7 +5311,7 @@
           </a:prstGeom>
         </p:spPr>
         <p:txBody>
-          <a:bodyPr anchor="t" rtlCol="false" tIns="0" lIns="0" bIns="0" rIns="0">
+          <a:bodyPr lIns="0" tIns="0" rIns="0" bIns="0" rtlCol="0" anchor="t">
             <a:spAutoFit/>
           </a:bodyPr>
           <a:lstStyle/>
@@ -5276,7 +5322,7 @@
               </a:lnSpc>
             </a:pPr>
             <a:r>
-              <a:rPr lang="en-US" sz="6287" b="true">
+              <a:rPr lang="en-US" sz="6287" b="1">
                 <a:solidFill>
                   <a:srgbClr val="000000"/>
                 </a:solidFill>
@@ -5299,13 +5345,14 @@
 </file>
 
 <file path=ppt/slides/slide7.xml><?xml version="1.0" encoding="utf-8"?>
-<p:sld xmlns:p="http://schemas.openxmlformats.org/presentationml/2006/main" xmlns:a="http://schemas.openxmlformats.org/drawingml/2006/main" xmlns:r="http://schemas.openxmlformats.org/officeDocument/2006/relationships">
+<p:sld xmlns:a="http://schemas.openxmlformats.org/drawingml/2006/main" xmlns:r="http://schemas.openxmlformats.org/officeDocument/2006/relationships" xmlns:p="http://schemas.openxmlformats.org/presentationml/2006/main">
   <p:cSld>
     <p:bg>
       <p:bgPr>
         <a:solidFill>
           <a:srgbClr val="F1F3F4"/>
         </a:solidFill>
+        <a:effectLst/>
       </p:bgPr>
     </p:bg>
     <p:spTree>
@@ -5324,12 +5371,12 @@
       </p:grpSpPr>
       <p:sp>
         <p:nvSpPr>
-          <p:cNvPr name="Freeform 2" id="2"/>
+          <p:cNvPr id="2" name="Freeform 2"/>
           <p:cNvSpPr/>
           <p:nvPr/>
         </p:nvSpPr>
         <p:spPr>
-          <a:xfrm flipH="false" flipV="false" rot="-885946">
+          <a:xfrm rot="-885946">
             <a:off x="11884251" y="-770733"/>
             <a:ext cx="10750098" cy="12447482"/>
           </a:xfrm>
@@ -5338,9 +5385,9 @@
             <a:gdLst/>
             <a:ahLst/>
             <a:cxnLst/>
-            <a:rect r="r" b="b" t="t" l="l"/>
+            <a:rect l="l" t="t" r="r" b="b"/>
             <a:pathLst>
-              <a:path h="12447482" w="10750098">
+              <a:path w="10750098" h="12447482">
                 <a:moveTo>
                   <a:pt x="0" y="0"/>
                 </a:moveTo>
@@ -5361,22 +5408,22 @@
             </a:pathLst>
           </a:custGeom>
           <a:blipFill>
-            <a:blip r:embed="rId2">
+            <a:blip>
               <a:extLst>
                 <a:ext uri="{96DAC541-7B7A-43D3-8B79-37D633B846F1}">
-                  <asvg:svgBlip xmlns:asvg="http://schemas.microsoft.com/office/drawing/2016/SVG/main" r:embed="rId3"/>
+                  <asvg:svgBlip xmlns:asvg="http://schemas.microsoft.com/office/drawing/2016/SVG/main" r:embed="rId2"/>
                 </a:ext>
               </a:extLst>
             </a:blip>
             <a:stretch>
-              <a:fillRect l="0" t="0" r="0" b="0"/>
+              <a:fillRect/>
             </a:stretch>
           </a:blipFill>
         </p:spPr>
       </p:sp>
       <p:sp>
         <p:nvSpPr>
-          <p:cNvPr name="AutoShape 3" id="3"/>
+          <p:cNvPr id="3" name="AutoShape 3"/>
           <p:cNvSpPr/>
           <p:nvPr/>
         </p:nvSpPr>
@@ -5388,24 +5435,24 @@
           <a:prstGeom prst="line">
             <a:avLst/>
           </a:prstGeom>
-          <a:ln cap="flat" w="38100">
+          <a:ln w="38100" cap="flat">
             <a:solidFill>
               <a:srgbClr val="000000"/>
             </a:solidFill>
             <a:prstDash val="solid"/>
-            <a:headEnd type="none" len="sm" w="sm"/>
-            <a:tailEnd type="none" len="sm" w="sm"/>
+            <a:headEnd type="none" w="sm" len="sm"/>
+            <a:tailEnd type="none" w="sm" len="sm"/>
           </a:ln>
         </p:spPr>
       </p:sp>
       <p:sp>
         <p:nvSpPr>
-          <p:cNvPr name="Freeform 4" id="4"/>
+          <p:cNvPr id="4" name="Freeform 4"/>
           <p:cNvSpPr/>
           <p:nvPr/>
         </p:nvSpPr>
         <p:spPr>
-          <a:xfrm flipH="false" flipV="false" rot="-10800000">
+          <a:xfrm rot="-10800000">
             <a:off x="0" y="6748170"/>
             <a:ext cx="7077660" cy="7077660"/>
           </a:xfrm>
@@ -5414,9 +5461,9 @@
             <a:gdLst/>
             <a:ahLst/>
             <a:cxnLst/>
-            <a:rect r="r" b="b" t="t" l="l"/>
+            <a:rect l="l" t="t" r="r" b="b"/>
             <a:pathLst>
-              <a:path h="7077660" w="7077660">
+              <a:path w="7077660" h="7077660">
                 <a:moveTo>
                   <a:pt x="0" y="0"/>
                 </a:moveTo>
@@ -5437,27 +5484,27 @@
             </a:pathLst>
           </a:custGeom>
           <a:blipFill>
-            <a:blip r:embed="rId4">
+            <a:blip>
               <a:extLst>
                 <a:ext uri="{96DAC541-7B7A-43D3-8B79-37D633B846F1}">
-                  <asvg:svgBlip xmlns:asvg="http://schemas.microsoft.com/office/drawing/2016/SVG/main" r:embed="rId5"/>
+                  <asvg:svgBlip xmlns:asvg="http://schemas.microsoft.com/office/drawing/2016/SVG/main" r:embed="rId3"/>
                 </a:ext>
               </a:extLst>
             </a:blip>
             <a:stretch>
-              <a:fillRect l="0" t="0" r="0" b="0"/>
+              <a:fillRect/>
             </a:stretch>
           </a:blipFill>
         </p:spPr>
       </p:sp>
       <p:sp>
         <p:nvSpPr>
-          <p:cNvPr name="TextBox 5" id="5"/>
-          <p:cNvSpPr txBox="true"/>
+          <p:cNvPr id="5" name="TextBox 5"/>
+          <p:cNvSpPr txBox="1"/>
           <p:nvPr/>
         </p:nvSpPr>
         <p:spPr>
-          <a:xfrm rot="0">
+          <a:xfrm>
             <a:off x="5115309" y="4145225"/>
             <a:ext cx="8057381" cy="1796524"/>
           </a:xfrm>
@@ -5466,7 +5513,7 @@
           </a:prstGeom>
         </p:spPr>
         <p:txBody>
-          <a:bodyPr anchor="t" rtlCol="false" tIns="0" lIns="0" bIns="0" rIns="0">
+          <a:bodyPr lIns="0" tIns="0" rIns="0" bIns="0" rtlCol="0" anchor="t">
             <a:spAutoFit/>
           </a:bodyPr>
           <a:lstStyle/>
@@ -5477,7 +5524,7 @@
               </a:lnSpc>
             </a:pPr>
             <a:r>
-              <a:rPr lang="en-US" b="true" sz="10528">
+              <a:rPr lang="en-US" sz="10528" b="1">
                 <a:solidFill>
                   <a:srgbClr val="00325A"/>
                 </a:solidFill>
@@ -5493,12 +5540,12 @@
       </p:sp>
       <p:sp>
         <p:nvSpPr>
-          <p:cNvPr name="TextBox 6" id="6"/>
-          <p:cNvSpPr txBox="true"/>
+          <p:cNvPr id="6" name="TextBox 6"/>
+          <p:cNvSpPr txBox="1"/>
           <p:nvPr/>
         </p:nvSpPr>
         <p:spPr>
-          <a:xfrm rot="0">
+          <a:xfrm>
             <a:off x="10106998" y="-168956"/>
             <a:ext cx="798705" cy="1197656"/>
           </a:xfrm>
@@ -5507,7 +5554,7 @@
           </a:prstGeom>
         </p:spPr>
         <p:txBody>
-          <a:bodyPr anchor="t" rtlCol="false" tIns="0" lIns="0" bIns="0" rIns="0">
+          <a:bodyPr lIns="0" tIns="0" rIns="0" bIns="0" rtlCol="0" anchor="t">
             <a:spAutoFit/>
           </a:bodyPr>
           <a:lstStyle/>
@@ -5518,7 +5565,7 @@
               </a:lnSpc>
             </a:pPr>
             <a:r>
-              <a:rPr lang="en-US" sz="6287" b="true">
+              <a:rPr lang="en-US" sz="6287" b="1">
                 <a:solidFill>
                   <a:srgbClr val="000000"/>
                 </a:solidFill>
@@ -5534,12 +5581,12 @@
       </p:sp>
       <p:sp>
         <p:nvSpPr>
-          <p:cNvPr name="TextBox 7" id="7"/>
-          <p:cNvSpPr txBox="true"/>
+          <p:cNvPr id="7" name="TextBox 7"/>
+          <p:cNvSpPr txBox="1"/>
           <p:nvPr/>
         </p:nvSpPr>
         <p:spPr>
-          <a:xfrm rot="0">
+          <a:xfrm>
             <a:off x="5056808" y="5732200"/>
             <a:ext cx="8174385" cy="1866584"/>
           </a:xfrm>
@@ -5548,7 +5595,7 @@
           </a:prstGeom>
         </p:spPr>
         <p:txBody>
-          <a:bodyPr anchor="t" rtlCol="false" tIns="0" lIns="0" bIns="0" rIns="0">
+          <a:bodyPr lIns="0" tIns="0" rIns="0" bIns="0" rtlCol="0" anchor="t">
             <a:spAutoFit/>
           </a:bodyPr>
           <a:lstStyle/>
@@ -5559,7 +5606,7 @@
               </a:lnSpc>
             </a:pPr>
             <a:r>
-              <a:rPr lang="en-US" sz="10887" b="true">
+              <a:rPr lang="en-US" sz="10887" b="1">
                 <a:solidFill>
                   <a:srgbClr val="000000"/>
                 </a:solidFill>

</xml_diff>